<commit_message>
Alinear entregables con el portafolio: comisión de 12 %, equilibrio ≈ 57 trabajos, 662,000 hogares, pregunta final de Idear y perfil del usuario completo
Co-Authored-By: Claude Opus 5.5 <noreply@anthropic.com>
</commit_message>
<xml_diff>
--- a/docs/Handyman_Presentacion_Final_20.pptx
+++ b/docs/Handyman_Presentacion_Final_20.pptx
@@ -1137,7 +1137,7 @@
           <a:p>
             <a:r>
               <a:rPr lang="en-US" dirty="0"/>
-              <a:t>Por qué así: el 61.9 % no pagaría más de 10 % extra, así que el cliente solo paga 1.5 % más y la comisión sale del margen del profesional. Cifras del piloto, a validar; pagos simulados en el MVP.</a:t>
+              <a:t>Por qué así: el 61.9 % no pagaría más de 10 % extra, así que el cliente solo paga 1.5 % más y la comisión de 12 % sale del margen del profesional. Con la meta de 75 trabajos quedan ≈ Q 1,500 al mes sobre el equilibrio. Cifras del piloto, a validar; pagos simulados en el MVP.</a:t>
             </a:r>
             <a:endParaRPr lang="en-US" dirty="0"/>
           </a:p>
@@ -1841,7 +1841,7 @@
           <a:p>
             <a:r>
               <a:rPr lang="en-US" dirty="0"/>
-              <a:t>Departamento de Guatemala: unos 3 millones de habitantes en el Censo 2018, con alrededor de 4 personas por hogar en zona urbana. 75 % y 1.5 trabajos al año salen de nuestra encuesta (76.2 % contrató 1 o 2). Q 1,000 por trabajo: el 47.6 % pagó entre Q 500 y Q 1,500.</a:t>
+              <a:t>Departamento de Guatemala: unos 3 millones de habitantes en el Censo 2018 (INE) ÷ 4.55 personas por hogar ≈ 662,000 hogares. 75 % y 1.5 trabajos al año salen de nuestra encuesta (76.2 % contrató 1 o 2). Q 1,000 por trabajo: el 47.6 % pagó entre Q 500 y Q 1,500.</a:t>
             </a:r>
             <a:endParaRPr lang="en-US" dirty="0"/>
           </a:p>
@@ -2105,7 +2105,7 @@
           <a:p>
             <a:r>
               <a:rPr lang="en-US" dirty="0"/>
-              <a:t>Usamos “garantizar” y no “conectar”: el 90.5 % ya encuentra a alguien. El problema es saber si lo hará bien.</a:t>
+              <a:t>Versión final de la pregunta, afinada en Idear. En Definir decía: ¿cómo podríamos garantizar que un trabajo del hogar quede bien hecho desde la primera vez? La afinamos porque comprobar identidad y capacidad antes de entrar es lo que el cliente puede verificar.</a:t>
             </a:r>
             <a:endParaRPr lang="en-US" dirty="0"/>
           </a:p>
@@ -10426,7 +10426,7 @@
                 <a:ea typeface="Calibri" pitchFamily="34" charset="-122"/>
                 <a:cs typeface="Calibri" pitchFamily="34" charset="-120"/>
               </a:rPr>
-              <a:t>El profesional cotiza; Handyman cobra 10 % de comisión y Q 15 de tarifa · trabajo promedio de Q 1,000</a:t>
+              <a:t>El profesional cotiza; Handyman cobra 12 % de comisión y Q 15 de tarifa · trabajo promedio de Q 1,000</a:t>
             </a:r>
             <a:endParaRPr lang="en-US" sz="1400" dirty="0"/>
           </a:p>
@@ -10767,7 +10767,7 @@
                 <a:ea typeface="Poppins" pitchFamily="34" charset="-122"/>
                 <a:cs typeface="Poppins" pitchFamily="34" charset="-120"/>
               </a:rPr>
-              <a:t>Q 900</a:t>
+              <a:t>Q 880</a:t>
             </a:r>
             <a:endParaRPr lang="en-US" sz="3000" dirty="0"/>
           </a:p>
@@ -10806,7 +10806,7 @@
                 <a:ea typeface="Calibri" pitchFamily="34" charset="-122"/>
                 <a:cs typeface="Calibri" pitchFamily="34" charset="-120"/>
               </a:rPr>
-              <a:t>Q 1,000 menos 10 % de comisión</a:t>
+              <a:t>Q 1,000 menos 12 % de comisión</a:t>
             </a:r>
             <a:endParaRPr lang="en-US" sz="1200" dirty="0"/>
           </a:p>
@@ -10911,7 +10911,7 @@
                 <a:ea typeface="Poppins" pitchFamily="34" charset="-122"/>
                 <a:cs typeface="Poppins" pitchFamily="34" charset="-120"/>
               </a:rPr>
-              <a:t>Q 115</a:t>
+              <a:t>Q 135</a:t>
             </a:r>
             <a:endParaRPr lang="en-US" sz="3000" dirty="0"/>
           </a:p>
@@ -10950,7 +10950,7 @@
                 <a:ea typeface="Calibri" pitchFamily="34" charset="-122"/>
                 <a:cs typeface="Calibri" pitchFamily="34" charset="-120"/>
               </a:rPr>
-              <a:t>Q 100 de comisión + Q 15 de tarifa</a:t>
+              <a:t>Q 120 de comisión + Q 15 de tarifa</a:t>
             </a:r>
             <a:endParaRPr lang="en-US" sz="1200" dirty="0"/>
           </a:p>
@@ -11094,7 +11094,7 @@
                 <a:ea typeface="Calibri" pitchFamily="34" charset="-122"/>
                 <a:cs typeface="Calibri" pitchFamily="34" charset="-120"/>
               </a:rPr>
-              <a:t>Variables: pasarela 4.5 % solo con tarjeta (≈ Q 32), fondo de garantía 2 % (Q 20), antecedentes de cada profesional y CAC menor a Q 50.</a:t>
+              <a:t>Variables: pasarela 4.5 % solo con tarjeta (4.5 % × Q 1,015 × 70 % que paga con tarjeta ≈ Q 32), fondo de garantía 2 % (Q 20), antecedentes de cada profesional y CAC menor a Q 50.</a:t>
             </a:r>
             <a:endParaRPr lang="en-US" sz="1250" dirty="0"/>
           </a:p>
@@ -11160,7 +11160,7 @@
                 <a:ea typeface="Poppins" pitchFamily="34" charset="-122"/>
                 <a:cs typeface="Poppins" pitchFamily="34" charset="-120"/>
               </a:rPr>
-              <a:t>Margen por trabajo: Q 115 − Q 32 − Q 20 = Q 63</a:t>
+              <a:t>Margen por trabajo: Q 135 − Q 32 − Q 20 = Q 83</a:t>
             </a:r>
             <a:endParaRPr lang="en-US" sz="1400" dirty="0"/>
           </a:p>
@@ -11199,7 +11199,7 @@
                 <a:ea typeface="Poppins" pitchFamily="34" charset="-122"/>
                 <a:cs typeface="Poppins" pitchFamily="34" charset="-120"/>
               </a:rPr>
-              <a:t>≈ 75 trabajos al mes</a:t>
+              <a:t>≈ 57 trabajos al mes</a:t>
             </a:r>
             <a:endParaRPr lang="en-US" sz="3000" dirty="0"/>
           </a:p>
@@ -11238,7 +11238,7 @@
                 <a:ea typeface="Calibri" pitchFamily="34" charset="-122"/>
                 <a:cs typeface="Calibri" pitchFamily="34" charset="-120"/>
               </a:rPr>
-              <a:t>Punto de equilibrio: Q 4,700 ÷ Q 63. Emergencias: visita a Q 150 fijo (Handyman retiene 25 %).</a:t>
+              <a:t>Punto de equilibrio: Q 4,700 ÷ Q 83. Meta del piloto: 75. Emergencias: visita a Q 150 fijo (Handyman retiene 25 %).</a:t>
             </a:r>
             <a:endParaRPr lang="en-US" sz="1300" dirty="0"/>
           </a:p>
@@ -12842,7 +12842,7 @@
                 <a:ea typeface="Calibri" pitchFamily="34" charset="-122"/>
                 <a:cs typeface="Calibri" pitchFamily="34" charset="-120"/>
               </a:rPr>
-              <a:t>trabajos (equilibrio)</a:t>
+              <a:t>trabajos (meta; equilibrio ≈ 57)</a:t>
             </a:r>
             <a:endParaRPr lang="en-US" sz="1200" dirty="0"/>
           </a:p>
@@ -17961,7 +17961,7 @@
                 <a:ea typeface="Poppins" pitchFamily="34" charset="-122"/>
                 <a:cs typeface="Poppins" pitchFamily="34" charset="-120"/>
               </a:rPr>
-              <a:t>≈ Q 840 millones al año</a:t>
+              <a:t>≈ Q 745 millones al año</a:t>
             </a:r>
             <a:endParaRPr lang="en-US" sz="2200" dirty="0"/>
           </a:p>
@@ -18000,7 +18000,7 @@
                 <a:ea typeface="Calibri" pitchFamily="34" charset="-122"/>
                 <a:cs typeface="Calibri" pitchFamily="34" charset="-120"/>
               </a:rPr>
-              <a:t>≈ 750,000 hogares del departamento de Guatemala × 75 % que contrata al menos un trabajo al año × 1.5 trabajos × Q 1,000 por trabajo</a:t>
+              <a:t>≈ 662,000 hogares del departamento de Guatemala × 75 % que contrata al menos un trabajo al año × 1.5 trabajos × Q 1,000 por trabajo</a:t>
             </a:r>
             <a:endParaRPr lang="en-US" sz="1250" dirty="0"/>
           </a:p>
@@ -18105,7 +18105,7 @@
                 <a:ea typeface="Poppins" pitchFamily="34" charset="-122"/>
                 <a:cs typeface="Poppins" pitchFamily="34" charset="-120"/>
               </a:rPr>
-              <a:t>≈ Q 210 millones al año</a:t>
+              <a:t>≈ Q 186 millones al año</a:t>
             </a:r>
             <a:endParaRPr lang="en-US" sz="2200" dirty="0"/>
           </a:p>
@@ -18288,7 +18288,7 @@
                 <a:ea typeface="Calibri" pitchFamily="34" charset="-122"/>
                 <a:cs typeface="Calibri" pitchFamily="34" charset="-120"/>
               </a:rPr>
-              <a:t>75 trabajos al mes (el punto de equilibrio) = 900 trabajos al año: menos del 0.5 % del mercado alcanzable</a:t>
+              <a:t>75 trabajos al mes (por encima del equilibrio de ≈ 57) = 900 trabajos al año: menos del 0.5 % del mercado alcanzable</a:t>
             </a:r>
             <a:endParaRPr lang="en-US" sz="1250" dirty="0"/>
           </a:p>
@@ -18601,18 +18601,792 @@
       </p:sp>
       <p:sp>
         <p:nvSpPr>
-          <p:cNvPr id="8" name="Shape 6"/>
-          <p:cNvSpPr/>
-          <p:nvPr/>
-        </p:nvSpPr>
-        <p:spPr>
-          <a:xfrm>
-            <a:off x="548640" y="1828800"/>
-            <a:ext cx="11064240" cy="1143000"/>
+          <p:cNvPr id="8" name="Text 6"/>
+          <p:cNvSpPr/>
+          <p:nvPr/>
+        </p:nvSpPr>
+        <p:spPr>
+          <a:xfrm>
+            <a:off x="548640" y="1783080"/>
+            <a:ext cx="5669280" cy="320040"/>
+          </a:xfrm>
+          <a:prstGeom prst="rect">
+            <a:avLst/>
+          </a:prstGeom>
+          <a:noFill/>
+          <a:ln/>
+        </p:spPr>
+        <p:txBody>
+          <a:bodyPr wrap="square" lIns="0" tIns="0" rIns="0" bIns="0" rtlCol="0" anchor="t"/>
+          <a:lstStyle/>
+          <a:p>
+            <a:pPr indent="0" marL="0">
+              <a:buNone/>
+            </a:pPr>
+            <a:r>
+              <a:rPr lang="en-US" sz="1500" b="1" dirty="0">
+                <a:solidFill>
+                  <a:srgbClr val="0B1020"/>
+                </a:solidFill>
+                <a:latin typeface="Poppins" pitchFamily="34" charset="0"/>
+                <a:ea typeface="Poppins" pitchFamily="34" charset="-122"/>
+                <a:cs typeface="Poppins" pitchFamily="34" charset="-120"/>
+              </a:rPr>
+              <a:t>Nuestro usuario</a:t>
+            </a:r>
+            <a:endParaRPr lang="en-US" sz="1500" dirty="0"/>
+          </a:p>
+        </p:txBody>
+      </p:sp>
+      <p:sp>
+        <p:nvSpPr>
+          <p:cNvPr id="9" name="Shape 7"/>
+          <p:cNvSpPr/>
+          <p:nvPr/>
+        </p:nvSpPr>
+        <p:spPr>
+          <a:xfrm>
+            <a:off x="548640" y="2148840"/>
+            <a:ext cx="5669280" cy="548640"/>
           </a:xfrm>
           <a:prstGeom prst="roundRect">
             <a:avLst>
-              <a:gd name="adj" fmla="val 9600"/>
+              <a:gd name="adj" fmla="val 20000"/>
+            </a:avLst>
+          </a:prstGeom>
+          <a:solidFill>
+            <a:srgbClr val="F5F6FA"/>
+          </a:solidFill>
+          <a:ln w="12700">
+            <a:solidFill>
+              <a:srgbClr val="E1E5EE"/>
+            </a:solidFill>
+            <a:prstDash val="solid"/>
+          </a:ln>
+        </p:spPr>
+      </p:sp>
+      <p:sp>
+        <p:nvSpPr>
+          <p:cNvPr id="10" name="Text 8"/>
+          <p:cNvSpPr/>
+          <p:nvPr/>
+        </p:nvSpPr>
+        <p:spPr>
+          <a:xfrm>
+            <a:off x="685800" y="2148840"/>
+            <a:ext cx="1463040" cy="548640"/>
+          </a:xfrm>
+          <a:prstGeom prst="rect">
+            <a:avLst/>
+          </a:prstGeom>
+          <a:noFill/>
+          <a:ln/>
+        </p:spPr>
+        <p:txBody>
+          <a:bodyPr wrap="square" lIns="0" tIns="0" rIns="0" bIns="0" rtlCol="0" anchor="ctr"/>
+          <a:lstStyle/>
+          <a:p>
+            <a:pPr indent="0" marL="0">
+              <a:buNone/>
+            </a:pPr>
+            <a:r>
+              <a:rPr lang="en-US" sz="1200" b="1" dirty="0">
+                <a:solidFill>
+                  <a:srgbClr val="E0A100"/>
+                </a:solidFill>
+                <a:latin typeface="Poppins" pitchFamily="34" charset="0"/>
+                <a:ea typeface="Poppins" pitchFamily="34" charset="-122"/>
+                <a:cs typeface="Poppins" pitchFamily="34" charset="-120"/>
+              </a:rPr>
+              <a:t>Edad</a:t>
+            </a:r>
+            <a:endParaRPr lang="en-US" sz="1200" dirty="0"/>
+          </a:p>
+        </p:txBody>
+      </p:sp>
+      <p:sp>
+        <p:nvSpPr>
+          <p:cNvPr id="11" name="Text 9"/>
+          <p:cNvSpPr/>
+          <p:nvPr/>
+        </p:nvSpPr>
+        <p:spPr>
+          <a:xfrm>
+            <a:off x="2148840" y="2148840"/>
+            <a:ext cx="3977640" cy="548640"/>
+          </a:xfrm>
+          <a:prstGeom prst="rect">
+            <a:avLst/>
+          </a:prstGeom>
+          <a:noFill/>
+          <a:ln/>
+        </p:spPr>
+        <p:txBody>
+          <a:bodyPr wrap="square" lIns="0" tIns="0" rIns="0" bIns="0" rtlCol="0" anchor="ctr"/>
+          <a:lstStyle/>
+          <a:p>
+            <a:pPr indent="0" marL="0">
+              <a:buNone/>
+            </a:pPr>
+            <a:r>
+              <a:rPr lang="en-US" sz="1150" dirty="0">
+                <a:solidFill>
+                  <a:srgbClr val="0B1020"/>
+                </a:solidFill>
+                <a:latin typeface="Calibri" pitchFamily="34" charset="0"/>
+                <a:ea typeface="Calibri" pitchFamily="34" charset="-122"/>
+                <a:cs typeface="Calibri" pitchFamily="34" charset="-120"/>
+              </a:rPr>
+              <a:t>30 a 60 años; 60.7 % entre 46 y 55 (Generación X). 53.6 % hombres, 46.4 % mujeres</a:t>
+            </a:r>
+            <a:endParaRPr lang="en-US" sz="1150" dirty="0"/>
+          </a:p>
+        </p:txBody>
+      </p:sp>
+      <p:sp>
+        <p:nvSpPr>
+          <p:cNvPr id="12" name="Shape 10"/>
+          <p:cNvSpPr/>
+          <p:nvPr/>
+        </p:nvSpPr>
+        <p:spPr>
+          <a:xfrm>
+            <a:off x="548640" y="2752344"/>
+            <a:ext cx="5669280" cy="548640"/>
+          </a:xfrm>
+          <a:prstGeom prst="roundRect">
+            <a:avLst>
+              <a:gd name="adj" fmla="val 20000"/>
+            </a:avLst>
+          </a:prstGeom>
+          <a:solidFill>
+            <a:srgbClr val="FFFFFF"/>
+          </a:solidFill>
+          <a:ln w="12700">
+            <a:solidFill>
+              <a:srgbClr val="E1E5EE"/>
+            </a:solidFill>
+            <a:prstDash val="solid"/>
+          </a:ln>
+        </p:spPr>
+      </p:sp>
+      <p:sp>
+        <p:nvSpPr>
+          <p:cNvPr id="13" name="Text 11"/>
+          <p:cNvSpPr/>
+          <p:nvPr/>
+        </p:nvSpPr>
+        <p:spPr>
+          <a:xfrm>
+            <a:off x="685800" y="2752344"/>
+            <a:ext cx="1463040" cy="548640"/>
+          </a:xfrm>
+          <a:prstGeom prst="rect">
+            <a:avLst/>
+          </a:prstGeom>
+          <a:noFill/>
+          <a:ln/>
+        </p:spPr>
+        <p:txBody>
+          <a:bodyPr wrap="square" lIns="0" tIns="0" rIns="0" bIns="0" rtlCol="0" anchor="ctr"/>
+          <a:lstStyle/>
+          <a:p>
+            <a:pPr indent="0" marL="0">
+              <a:buNone/>
+            </a:pPr>
+            <a:r>
+              <a:rPr lang="en-US" sz="1200" b="1" dirty="0">
+                <a:solidFill>
+                  <a:srgbClr val="E0A100"/>
+                </a:solidFill>
+                <a:latin typeface="Poppins" pitchFamily="34" charset="0"/>
+                <a:ea typeface="Poppins" pitchFamily="34" charset="-122"/>
+                <a:cs typeface="Poppins" pitchFamily="34" charset="-120"/>
+              </a:rPr>
+              <a:t>Ingresos</a:t>
+            </a:r>
+            <a:endParaRPr lang="en-US" sz="1200" dirty="0"/>
+          </a:p>
+        </p:txBody>
+      </p:sp>
+      <p:sp>
+        <p:nvSpPr>
+          <p:cNvPr id="14" name="Text 12"/>
+          <p:cNvSpPr/>
+          <p:nvPr/>
+        </p:nvSpPr>
+        <p:spPr>
+          <a:xfrm>
+            <a:off x="2148840" y="2752344"/>
+            <a:ext cx="3977640" cy="548640"/>
+          </a:xfrm>
+          <a:prstGeom prst="rect">
+            <a:avLst/>
+          </a:prstGeom>
+          <a:noFill/>
+          <a:ln/>
+        </p:spPr>
+        <p:txBody>
+          <a:bodyPr wrap="square" lIns="0" tIns="0" rIns="0" bIns="0" rtlCol="0" anchor="ctr"/>
+          <a:lstStyle/>
+          <a:p>
+            <a:pPr indent="0" marL="0">
+              <a:buNone/>
+            </a:pPr>
+            <a:r>
+              <a:rPr lang="en-US" sz="1150" dirty="0">
+                <a:solidFill>
+                  <a:srgbClr val="0B1020"/>
+                </a:solidFill>
+                <a:latin typeface="Calibri" pitchFamily="34" charset="0"/>
+                <a:ea typeface="Calibri" pitchFamily="34" charset="-122"/>
+                <a:cs typeface="Calibri" pitchFamily="34" charset="-120"/>
+              </a:rPr>
+              <a:t>Medios y medio-altos, formales</a:t>
+            </a:r>
+            <a:endParaRPr lang="en-US" sz="1150" dirty="0"/>
+          </a:p>
+        </p:txBody>
+      </p:sp>
+      <p:sp>
+        <p:nvSpPr>
+          <p:cNvPr id="15" name="Shape 13"/>
+          <p:cNvSpPr/>
+          <p:nvPr/>
+        </p:nvSpPr>
+        <p:spPr>
+          <a:xfrm>
+            <a:off x="548640" y="3355848"/>
+            <a:ext cx="5669280" cy="548640"/>
+          </a:xfrm>
+          <a:prstGeom prst="roundRect">
+            <a:avLst>
+              <a:gd name="adj" fmla="val 20000"/>
+            </a:avLst>
+          </a:prstGeom>
+          <a:solidFill>
+            <a:srgbClr val="F5F6FA"/>
+          </a:solidFill>
+          <a:ln w="12700">
+            <a:solidFill>
+              <a:srgbClr val="E1E5EE"/>
+            </a:solidFill>
+            <a:prstDash val="solid"/>
+          </a:ln>
+        </p:spPr>
+      </p:sp>
+      <p:sp>
+        <p:nvSpPr>
+          <p:cNvPr id="16" name="Text 14"/>
+          <p:cNvSpPr/>
+          <p:nvPr/>
+        </p:nvSpPr>
+        <p:spPr>
+          <a:xfrm>
+            <a:off x="685800" y="3355848"/>
+            <a:ext cx="1463040" cy="548640"/>
+          </a:xfrm>
+          <a:prstGeom prst="rect">
+            <a:avLst/>
+          </a:prstGeom>
+          <a:noFill/>
+          <a:ln/>
+        </p:spPr>
+        <p:txBody>
+          <a:bodyPr wrap="square" lIns="0" tIns="0" rIns="0" bIns="0" rtlCol="0" anchor="ctr"/>
+          <a:lstStyle/>
+          <a:p>
+            <a:pPr indent="0" marL="0">
+              <a:buNone/>
+            </a:pPr>
+            <a:r>
+              <a:rPr lang="en-US" sz="1200" b="1" dirty="0">
+                <a:solidFill>
+                  <a:srgbClr val="E0A100"/>
+                </a:solidFill>
+                <a:latin typeface="Poppins" pitchFamily="34" charset="0"/>
+                <a:ea typeface="Poppins" pitchFamily="34" charset="-122"/>
+                <a:cs typeface="Poppins" pitchFamily="34" charset="-120"/>
+              </a:rPr>
+              <a:t>Educación</a:t>
+            </a:r>
+            <a:endParaRPr lang="en-US" sz="1200" dirty="0"/>
+          </a:p>
+        </p:txBody>
+      </p:sp>
+      <p:sp>
+        <p:nvSpPr>
+          <p:cNvPr id="17" name="Text 15"/>
+          <p:cNvSpPr/>
+          <p:nvPr/>
+        </p:nvSpPr>
+        <p:spPr>
+          <a:xfrm>
+            <a:off x="2148840" y="3355848"/>
+            <a:ext cx="3977640" cy="548640"/>
+          </a:xfrm>
+          <a:prstGeom prst="rect">
+            <a:avLst/>
+          </a:prstGeom>
+          <a:noFill/>
+          <a:ln/>
+        </p:spPr>
+        <p:txBody>
+          <a:bodyPr wrap="square" lIns="0" tIns="0" rIns="0" bIns="0" rtlCol="0" anchor="ctr"/>
+          <a:lstStyle/>
+          <a:p>
+            <a:pPr indent="0" marL="0">
+              <a:buNone/>
+            </a:pPr>
+            <a:r>
+              <a:rPr lang="en-US" sz="1150" dirty="0">
+                <a:solidFill>
+                  <a:srgbClr val="0B1020"/>
+                </a:solidFill>
+                <a:latin typeface="Calibri" pitchFamily="34" charset="0"/>
+                <a:ea typeface="Calibri" pitchFamily="34" charset="-122"/>
+                <a:cs typeface="Calibri" pitchFamily="34" charset="-120"/>
+              </a:rPr>
+              <a:t>Mayormente universitaria</a:t>
+            </a:r>
+            <a:endParaRPr lang="en-US" sz="1150" dirty="0"/>
+          </a:p>
+        </p:txBody>
+      </p:sp>
+      <p:sp>
+        <p:nvSpPr>
+          <p:cNvPr id="18" name="Shape 16"/>
+          <p:cNvSpPr/>
+          <p:nvPr/>
+        </p:nvSpPr>
+        <p:spPr>
+          <a:xfrm>
+            <a:off x="548640" y="3959352"/>
+            <a:ext cx="5669280" cy="548640"/>
+          </a:xfrm>
+          <a:prstGeom prst="roundRect">
+            <a:avLst>
+              <a:gd name="adj" fmla="val 20000"/>
+            </a:avLst>
+          </a:prstGeom>
+          <a:solidFill>
+            <a:srgbClr val="FFFFFF"/>
+          </a:solidFill>
+          <a:ln w="12700">
+            <a:solidFill>
+              <a:srgbClr val="E1E5EE"/>
+            </a:solidFill>
+            <a:prstDash val="solid"/>
+          </a:ln>
+        </p:spPr>
+      </p:sp>
+      <p:sp>
+        <p:nvSpPr>
+          <p:cNvPr id="19" name="Text 17"/>
+          <p:cNvSpPr/>
+          <p:nvPr/>
+        </p:nvSpPr>
+        <p:spPr>
+          <a:xfrm>
+            <a:off x="685800" y="3959352"/>
+            <a:ext cx="1463040" cy="548640"/>
+          </a:xfrm>
+          <a:prstGeom prst="rect">
+            <a:avLst/>
+          </a:prstGeom>
+          <a:noFill/>
+          <a:ln/>
+        </p:spPr>
+        <p:txBody>
+          <a:bodyPr wrap="square" lIns="0" tIns="0" rIns="0" bIns="0" rtlCol="0" anchor="ctr"/>
+          <a:lstStyle/>
+          <a:p>
+            <a:pPr indent="0" marL="0">
+              <a:buNone/>
+            </a:pPr>
+            <a:r>
+              <a:rPr lang="en-US" sz="1200" b="1" dirty="0">
+                <a:solidFill>
+                  <a:srgbClr val="E0A100"/>
+                </a:solidFill>
+                <a:latin typeface="Poppins" pitchFamily="34" charset="0"/>
+                <a:ea typeface="Poppins" pitchFamily="34" charset="-122"/>
+                <a:cs typeface="Poppins" pitchFamily="34" charset="-120"/>
+              </a:rPr>
+              <a:t>Ocupación</a:t>
+            </a:r>
+            <a:endParaRPr lang="en-US" sz="1200" dirty="0"/>
+          </a:p>
+        </p:txBody>
+      </p:sp>
+      <p:sp>
+        <p:nvSpPr>
+          <p:cNvPr id="20" name="Text 18"/>
+          <p:cNvSpPr/>
+          <p:nvPr/>
+        </p:nvSpPr>
+        <p:spPr>
+          <a:xfrm>
+            <a:off x="2148840" y="3959352"/>
+            <a:ext cx="3977640" cy="548640"/>
+          </a:xfrm>
+          <a:prstGeom prst="rect">
+            <a:avLst/>
+          </a:prstGeom>
+          <a:noFill/>
+          <a:ln/>
+        </p:spPr>
+        <p:txBody>
+          <a:bodyPr wrap="square" lIns="0" tIns="0" rIns="0" bIns="0" rtlCol="0" anchor="ctr"/>
+          <a:lstStyle/>
+          <a:p>
+            <a:pPr indent="0" marL="0">
+              <a:buNone/>
+            </a:pPr>
+            <a:r>
+              <a:rPr lang="en-US" sz="1150" dirty="0">
+                <a:solidFill>
+                  <a:srgbClr val="0B1020"/>
+                </a:solidFill>
+                <a:latin typeface="Calibri" pitchFamily="34" charset="0"/>
+                <a:ea typeface="Calibri" pitchFamily="34" charset="-122"/>
+                <a:cs typeface="Calibri" pitchFamily="34" charset="-120"/>
+              </a:rPr>
+              <a:t>Profesional liberal 32.1 % · comercio 25 % · oficina 17.9 %</a:t>
+            </a:r>
+            <a:endParaRPr lang="en-US" sz="1150" dirty="0"/>
+          </a:p>
+        </p:txBody>
+      </p:sp>
+      <p:sp>
+        <p:nvSpPr>
+          <p:cNvPr id="21" name="Shape 19"/>
+          <p:cNvSpPr/>
+          <p:nvPr/>
+        </p:nvSpPr>
+        <p:spPr>
+          <a:xfrm>
+            <a:off x="548640" y="4562856"/>
+            <a:ext cx="5669280" cy="548640"/>
+          </a:xfrm>
+          <a:prstGeom prst="roundRect">
+            <a:avLst>
+              <a:gd name="adj" fmla="val 20000"/>
+            </a:avLst>
+          </a:prstGeom>
+          <a:solidFill>
+            <a:srgbClr val="F5F6FA"/>
+          </a:solidFill>
+          <a:ln w="12700">
+            <a:solidFill>
+              <a:srgbClr val="E1E5EE"/>
+            </a:solidFill>
+            <a:prstDash val="solid"/>
+          </a:ln>
+        </p:spPr>
+      </p:sp>
+      <p:sp>
+        <p:nvSpPr>
+          <p:cNvPr id="22" name="Text 20"/>
+          <p:cNvSpPr/>
+          <p:nvPr/>
+        </p:nvSpPr>
+        <p:spPr>
+          <a:xfrm>
+            <a:off x="685800" y="4562856"/>
+            <a:ext cx="1463040" cy="548640"/>
+          </a:xfrm>
+          <a:prstGeom prst="rect">
+            <a:avLst/>
+          </a:prstGeom>
+          <a:noFill/>
+          <a:ln/>
+        </p:spPr>
+        <p:txBody>
+          <a:bodyPr wrap="square" lIns="0" tIns="0" rIns="0" bIns="0" rtlCol="0" anchor="ctr"/>
+          <a:lstStyle/>
+          <a:p>
+            <a:pPr indent="0" marL="0">
+              <a:buNone/>
+            </a:pPr>
+            <a:r>
+              <a:rPr lang="en-US" sz="1200" b="1" dirty="0">
+                <a:solidFill>
+                  <a:srgbClr val="E0A100"/>
+                </a:solidFill>
+                <a:latin typeface="Poppins" pitchFamily="34" charset="0"/>
+                <a:ea typeface="Poppins" pitchFamily="34" charset="-122"/>
+                <a:cs typeface="Poppins" pitchFamily="34" charset="-120"/>
+              </a:rPr>
+              <a:t>Vivienda</a:t>
+            </a:r>
+            <a:endParaRPr lang="en-US" sz="1200" dirty="0"/>
+          </a:p>
+        </p:txBody>
+      </p:sp>
+      <p:sp>
+        <p:nvSpPr>
+          <p:cNvPr id="23" name="Text 21"/>
+          <p:cNvSpPr/>
+          <p:nvPr/>
+        </p:nvSpPr>
+        <p:spPr>
+          <a:xfrm>
+            <a:off x="2148840" y="4562856"/>
+            <a:ext cx="3977640" cy="548640"/>
+          </a:xfrm>
+          <a:prstGeom prst="rect">
+            <a:avLst/>
+          </a:prstGeom>
+          <a:noFill/>
+          <a:ln/>
+        </p:spPr>
+        <p:txBody>
+          <a:bodyPr wrap="square" lIns="0" tIns="0" rIns="0" bIns="0" rtlCol="0" anchor="ctr"/>
+          <a:lstStyle/>
+          <a:p>
+            <a:pPr indent="0" marL="0">
+              <a:buNone/>
+            </a:pPr>
+            <a:r>
+              <a:rPr lang="en-US" sz="1150" dirty="0">
+                <a:solidFill>
+                  <a:srgbClr val="0B1020"/>
+                </a:solidFill>
+                <a:latin typeface="Calibri" pitchFamily="34" charset="0"/>
+                <a:ea typeface="Calibri" pitchFamily="34" charset="-122"/>
+                <a:cs typeface="Calibri" pitchFamily="34" charset="-120"/>
+              </a:rPr>
+              <a:t>Casa propia 82.1 %; Ciudad de Guatemala 42.9 % y Mixco 21.4 %</a:t>
+            </a:r>
+            <a:endParaRPr lang="en-US" sz="1150" dirty="0"/>
+          </a:p>
+        </p:txBody>
+      </p:sp>
+      <p:sp>
+        <p:nvSpPr>
+          <p:cNvPr id="24" name="Shape 22"/>
+          <p:cNvSpPr/>
+          <p:nvPr/>
+        </p:nvSpPr>
+        <p:spPr>
+          <a:xfrm>
+            <a:off x="548640" y="5166360"/>
+            <a:ext cx="5669280" cy="548640"/>
+          </a:xfrm>
+          <a:prstGeom prst="roundRect">
+            <a:avLst>
+              <a:gd name="adj" fmla="val 20000"/>
+            </a:avLst>
+          </a:prstGeom>
+          <a:solidFill>
+            <a:srgbClr val="FFFFFF"/>
+          </a:solidFill>
+          <a:ln w="12700">
+            <a:solidFill>
+              <a:srgbClr val="E1E5EE"/>
+            </a:solidFill>
+            <a:prstDash val="solid"/>
+          </a:ln>
+        </p:spPr>
+      </p:sp>
+      <p:sp>
+        <p:nvSpPr>
+          <p:cNvPr id="25" name="Text 23"/>
+          <p:cNvSpPr/>
+          <p:nvPr/>
+        </p:nvSpPr>
+        <p:spPr>
+          <a:xfrm>
+            <a:off x="685800" y="5166360"/>
+            <a:ext cx="1463040" cy="548640"/>
+          </a:xfrm>
+          <a:prstGeom prst="rect">
+            <a:avLst/>
+          </a:prstGeom>
+          <a:noFill/>
+          <a:ln/>
+        </p:spPr>
+        <p:txBody>
+          <a:bodyPr wrap="square" lIns="0" tIns="0" rIns="0" bIns="0" rtlCol="0" anchor="ctr"/>
+          <a:lstStyle/>
+          <a:p>
+            <a:pPr indent="0" marL="0">
+              <a:buNone/>
+            </a:pPr>
+            <a:r>
+              <a:rPr lang="en-US" sz="1200" b="1" dirty="0">
+                <a:solidFill>
+                  <a:srgbClr val="E0A100"/>
+                </a:solidFill>
+                <a:latin typeface="Poppins" pitchFamily="34" charset="0"/>
+                <a:ea typeface="Poppins" pitchFamily="34" charset="-122"/>
+                <a:cs typeface="Poppins" pitchFamily="34" charset="-120"/>
+              </a:rPr>
+              <a:t>Compra</a:t>
+            </a:r>
+            <a:endParaRPr lang="en-US" sz="1200" dirty="0"/>
+          </a:p>
+        </p:txBody>
+      </p:sp>
+      <p:sp>
+        <p:nvSpPr>
+          <p:cNvPr id="26" name="Text 24"/>
+          <p:cNvSpPr/>
+          <p:nvPr/>
+        </p:nvSpPr>
+        <p:spPr>
+          <a:xfrm>
+            <a:off x="2148840" y="5166360"/>
+            <a:ext cx="3977640" cy="548640"/>
+          </a:xfrm>
+          <a:prstGeom prst="rect">
+            <a:avLst/>
+          </a:prstGeom>
+          <a:noFill/>
+          <a:ln/>
+        </p:spPr>
+        <p:txBody>
+          <a:bodyPr wrap="square" lIns="0" tIns="0" rIns="0" bIns="0" rtlCol="0" anchor="ctr"/>
+          <a:lstStyle/>
+          <a:p>
+            <a:pPr indent="0" marL="0">
+              <a:buNone/>
+            </a:pPr>
+            <a:r>
+              <a:rPr lang="en-US" sz="1150" dirty="0">
+                <a:solidFill>
+                  <a:srgbClr val="0B1020"/>
+                </a:solidFill>
+                <a:latin typeface="Calibri" pitchFamily="34" charset="0"/>
+                <a:ea typeface="Calibri" pitchFamily="34" charset="-122"/>
+                <a:cs typeface="Calibri" pitchFamily="34" charset="-120"/>
+              </a:rPr>
+              <a:t>1 o 2 trabajos al año (76.2 %), de Q 500 a Q 1,500 (47.6 %)</a:t>
+            </a:r>
+            <a:endParaRPr lang="en-US" sz="1150" dirty="0"/>
+          </a:p>
+        </p:txBody>
+      </p:sp>
+      <p:sp>
+        <p:nvSpPr>
+          <p:cNvPr id="27" name="Shape 25"/>
+          <p:cNvSpPr/>
+          <p:nvPr/>
+        </p:nvSpPr>
+        <p:spPr>
+          <a:xfrm>
+            <a:off x="548640" y="5769864"/>
+            <a:ext cx="5669280" cy="548640"/>
+          </a:xfrm>
+          <a:prstGeom prst="roundRect">
+            <a:avLst>
+              <a:gd name="adj" fmla="val 20000"/>
+            </a:avLst>
+          </a:prstGeom>
+          <a:solidFill>
+            <a:srgbClr val="FFF4DC"/>
+          </a:solidFill>
+          <a:ln w="12700">
+            <a:solidFill>
+              <a:srgbClr val="E1E5EE"/>
+            </a:solidFill>
+            <a:prstDash val="solid"/>
+          </a:ln>
+        </p:spPr>
+      </p:sp>
+      <p:sp>
+        <p:nvSpPr>
+          <p:cNvPr id="28" name="Text 26"/>
+          <p:cNvSpPr/>
+          <p:nvPr/>
+        </p:nvSpPr>
+        <p:spPr>
+          <a:xfrm>
+            <a:off x="685800" y="5769864"/>
+            <a:ext cx="1463040" cy="548640"/>
+          </a:xfrm>
+          <a:prstGeom prst="rect">
+            <a:avLst/>
+          </a:prstGeom>
+          <a:noFill/>
+          <a:ln/>
+        </p:spPr>
+        <p:txBody>
+          <a:bodyPr wrap="square" lIns="0" tIns="0" rIns="0" bIns="0" rtlCol="0" anchor="ctr"/>
+          <a:lstStyle/>
+          <a:p>
+            <a:pPr indent="0" marL="0">
+              <a:buNone/>
+            </a:pPr>
+            <a:r>
+              <a:rPr lang="en-US" sz="1200" b="1" dirty="0">
+                <a:solidFill>
+                  <a:srgbClr val="B86E00"/>
+                </a:solidFill>
+                <a:latin typeface="Poppins" pitchFamily="34" charset="0"/>
+                <a:ea typeface="Poppins" pitchFamily="34" charset="-122"/>
+                <a:cs typeface="Poppins" pitchFamily="34" charset="-120"/>
+              </a:rPr>
+              <a:t>Early adopters</a:t>
+            </a:r>
+            <a:endParaRPr lang="en-US" sz="1200" dirty="0"/>
+          </a:p>
+        </p:txBody>
+      </p:sp>
+      <p:sp>
+        <p:nvSpPr>
+          <p:cNvPr id="29" name="Text 27"/>
+          <p:cNvSpPr/>
+          <p:nvPr/>
+        </p:nvSpPr>
+        <p:spPr>
+          <a:xfrm>
+            <a:off x="2148840" y="5769864"/>
+            <a:ext cx="3977640" cy="548640"/>
+          </a:xfrm>
+          <a:prstGeom prst="rect">
+            <a:avLst/>
+          </a:prstGeom>
+          <a:noFill/>
+          <a:ln/>
+        </p:spPr>
+        <p:txBody>
+          <a:bodyPr wrap="square" lIns="0" tIns="0" rIns="0" bIns="0" rtlCol="0" anchor="ctr"/>
+          <a:lstStyle/>
+          <a:p>
+            <a:pPr indent="0" marL="0">
+              <a:buNone/>
+            </a:pPr>
+            <a:r>
+              <a:rPr lang="en-US" sz="1150" dirty="0">
+                <a:solidFill>
+                  <a:srgbClr val="0B1020"/>
+                </a:solidFill>
+                <a:latin typeface="Calibri" pitchFamily="34" charset="0"/>
+                <a:ea typeface="Calibri" pitchFamily="34" charset="-122"/>
+                <a:cs typeface="Calibri" pitchFamily="34" charset="-120"/>
+              </a:rPr>
+              <a:t>Residentes de condominios de zonas 10 a 16</a:t>
+            </a:r>
+            <a:endParaRPr lang="en-US" sz="1150" dirty="0"/>
+          </a:p>
+        </p:txBody>
+      </p:sp>
+      <p:sp>
+        <p:nvSpPr>
+          <p:cNvPr id="30" name="Shape 28"/>
+          <p:cNvSpPr/>
+          <p:nvPr/>
+        </p:nvSpPr>
+        <p:spPr>
+          <a:xfrm>
+            <a:off x="6446520" y="1783080"/>
+            <a:ext cx="2468880" cy="1463040"/>
+          </a:xfrm>
+          <a:prstGeom prst="roundRect">
+            <a:avLst>
+              <a:gd name="adj" fmla="val 7500"/>
             </a:avLst>
           </a:prstGeom>
           <a:solidFill>
@@ -18628,53 +19402,92 @@
       </p:sp>
       <p:sp>
         <p:nvSpPr>
-          <p:cNvPr id="9" name="Text 7"/>
-          <p:cNvSpPr/>
-          <p:nvPr/>
-        </p:nvSpPr>
-        <p:spPr>
-          <a:xfrm>
-            <a:off x="822960" y="1874520"/>
-            <a:ext cx="10515600" cy="1051560"/>
-          </a:xfrm>
-          <a:prstGeom prst="rect">
-            <a:avLst/>
-          </a:prstGeom>
-          <a:noFill/>
-          <a:ln/>
-        </p:spPr>
-        <p:txBody>
-          <a:bodyPr wrap="square" lIns="0" tIns="0" rIns="0" bIns="0" rtlCol="0" anchor="ctr"/>
-          <a:lstStyle/>
-          <a:p>
-            <a:pPr indent="0" marL="0">
-              <a:buNone/>
-            </a:pPr>
-            <a:r>
-              <a:rPr lang="en-US" sz="1500" dirty="0">
-                <a:solidFill>
-                  <a:srgbClr val="0B1020"/>
+          <p:cNvPr id="31" name="Text 29"/>
+          <p:cNvSpPr/>
+          <p:nvPr/>
+        </p:nvSpPr>
+        <p:spPr>
+          <a:xfrm>
+            <a:off x="6629400" y="1920240"/>
+            <a:ext cx="2103120" cy="685800"/>
+          </a:xfrm>
+          <a:prstGeom prst="rect">
+            <a:avLst/>
+          </a:prstGeom>
+          <a:noFill/>
+          <a:ln/>
+        </p:spPr>
+        <p:txBody>
+          <a:bodyPr wrap="square" lIns="0" tIns="0" rIns="0" bIns="0" rtlCol="0" anchor="t"/>
+          <a:lstStyle/>
+          <a:p>
+            <a:pPr indent="0" marL="0">
+              <a:buNone/>
+            </a:pPr>
+            <a:r>
+              <a:rPr lang="en-US" sz="3400" b="1" dirty="0">
+                <a:solidFill>
+                  <a:srgbClr val="E0A100"/>
+                </a:solidFill>
+                <a:latin typeface="Poppins" pitchFamily="34" charset="0"/>
+                <a:ea typeface="Poppins" pitchFamily="34" charset="-122"/>
+                <a:cs typeface="Poppins" pitchFamily="34" charset="-120"/>
+              </a:rPr>
+              <a:t>90.5 %</a:t>
+            </a:r>
+            <a:endParaRPr lang="en-US" sz="3400" dirty="0"/>
+          </a:p>
+        </p:txBody>
+      </p:sp>
+      <p:sp>
+        <p:nvSpPr>
+          <p:cNvPr id="32" name="Text 30"/>
+          <p:cNvSpPr/>
+          <p:nvPr/>
+        </p:nvSpPr>
+        <p:spPr>
+          <a:xfrm>
+            <a:off x="6629400" y="2606040"/>
+            <a:ext cx="2103120" cy="548640"/>
+          </a:xfrm>
+          <a:prstGeom prst="rect">
+            <a:avLst/>
+          </a:prstGeom>
+          <a:noFill/>
+          <a:ln/>
+        </p:spPr>
+        <p:txBody>
+          <a:bodyPr wrap="square" lIns="0" tIns="0" rIns="0" bIns="0" rtlCol="0" anchor="t"/>
+          <a:lstStyle/>
+          <a:p>
+            <a:pPr indent="0" marL="0">
+              <a:buNone/>
+            </a:pPr>
+            <a:r>
+              <a:rPr lang="en-US" sz="1300" dirty="0">
+                <a:solidFill>
+                  <a:srgbClr val="434C63"/>
                 </a:solidFill>
                 <a:latin typeface="Calibri" pitchFamily="34" charset="0"/>
                 <a:ea typeface="Calibri" pitchFamily="34" charset="-122"/>
                 <a:cs typeface="Calibri" pitchFamily="34" charset="-120"/>
               </a:rPr>
-              <a:t>Perfil: adulto de 30 a 60 años (60.7 % entre 46 y 55), dueño de su casa (82.1 %) en la Ciudad de Guatemala o Mixco, con poco tiempo. Contrata 1 o 2 trabajos al año y paga entre Q 500 y Q 1,500.</a:t>
-            </a:r>
-            <a:endParaRPr lang="en-US" sz="1500" dirty="0"/>
-          </a:p>
-        </p:txBody>
-      </p:sp>
-      <p:sp>
-        <p:nvSpPr>
-          <p:cNvPr id="10" name="Shape 8"/>
-          <p:cNvSpPr/>
-          <p:nvPr/>
-        </p:nvSpPr>
-        <p:spPr>
-          <a:xfrm>
-            <a:off x="548640" y="3200400"/>
-            <a:ext cx="3520440" cy="1463040"/>
+              <a:t>contrató por recomendación de un conocido</a:t>
+            </a:r>
+            <a:endParaRPr lang="en-US" sz="1300" dirty="0"/>
+          </a:p>
+        </p:txBody>
+      </p:sp>
+      <p:sp>
+        <p:nvSpPr>
+          <p:cNvPr id="33" name="Shape 31"/>
+          <p:cNvSpPr/>
+          <p:nvPr/>
+        </p:nvSpPr>
+        <p:spPr>
+          <a:xfrm>
+            <a:off x="9052560" y="1783080"/>
+            <a:ext cx="2468880" cy="1463040"/>
           </a:xfrm>
           <a:prstGeom prst="roundRect">
             <a:avLst>
@@ -18694,14 +19507,14 @@
       </p:sp>
       <p:sp>
         <p:nvSpPr>
-          <p:cNvPr id="11" name="Text 9"/>
-          <p:cNvSpPr/>
-          <p:nvPr/>
-        </p:nvSpPr>
-        <p:spPr>
-          <a:xfrm>
-            <a:off x="731520" y="3337560"/>
-            <a:ext cx="3154680" cy="685800"/>
+          <p:cNvPr id="34" name="Text 32"/>
+          <p:cNvSpPr/>
+          <p:nvPr/>
+        </p:nvSpPr>
+        <p:spPr>
+          <a:xfrm>
+            <a:off x="9235440" y="1920240"/>
+            <a:ext cx="2103120" cy="685800"/>
           </a:xfrm>
           <a:prstGeom prst="rect">
             <a:avLst/>
@@ -18725,7 +19538,7 @@
                 <a:ea typeface="Poppins" pitchFamily="34" charset="-122"/>
                 <a:cs typeface="Poppins" pitchFamily="34" charset="-120"/>
               </a:rPr>
-              <a:t>90.5 %</a:t>
+              <a:t>100 %</a:t>
             </a:r>
             <a:endParaRPr lang="en-US" sz="3400" dirty="0"/>
           </a:p>
@@ -18733,14 +19546,14 @@
       </p:sp>
       <p:sp>
         <p:nvSpPr>
-          <p:cNvPr id="12" name="Text 10"/>
-          <p:cNvSpPr/>
-          <p:nvPr/>
-        </p:nvSpPr>
-        <p:spPr>
-          <a:xfrm>
-            <a:off x="731520" y="4023360"/>
-            <a:ext cx="3154680" cy="548640"/>
+          <p:cNvPr id="35" name="Text 33"/>
+          <p:cNvSpPr/>
+          <p:nvPr/>
+        </p:nvSpPr>
+        <p:spPr>
+          <a:xfrm>
+            <a:off x="9235440" y="2606040"/>
+            <a:ext cx="2103120" cy="548640"/>
           </a:xfrm>
           <a:prstGeom prst="rect">
             <a:avLst/>
@@ -18764,7 +19577,7 @@
                 <a:ea typeface="Calibri" pitchFamily="34" charset="-122"/>
                 <a:cs typeface="Calibri" pitchFamily="34" charset="-120"/>
               </a:rPr>
-              <a:t>contrató por recomendación de un conocido</a:t>
+              <a:t>nunca usó una app para esto</a:t>
             </a:r>
             <a:endParaRPr lang="en-US" sz="1300" dirty="0"/>
           </a:p>
@@ -18772,14 +19585,14 @@
       </p:sp>
       <p:sp>
         <p:nvSpPr>
-          <p:cNvPr id="13" name="Shape 11"/>
-          <p:cNvSpPr/>
-          <p:nvPr/>
-        </p:nvSpPr>
-        <p:spPr>
-          <a:xfrm>
-            <a:off x="4297680" y="3200400"/>
-            <a:ext cx="3520440" cy="1463040"/>
+          <p:cNvPr id="36" name="Shape 34"/>
+          <p:cNvSpPr/>
+          <p:nvPr/>
+        </p:nvSpPr>
+        <p:spPr>
+          <a:xfrm>
+            <a:off x="6446520" y="3319272"/>
+            <a:ext cx="2468880" cy="1463040"/>
           </a:xfrm>
           <a:prstGeom prst="roundRect">
             <a:avLst>
@@ -18799,14 +19612,14 @@
       </p:sp>
       <p:sp>
         <p:nvSpPr>
-          <p:cNvPr id="14" name="Text 12"/>
-          <p:cNvSpPr/>
-          <p:nvPr/>
-        </p:nvSpPr>
-        <p:spPr>
-          <a:xfrm>
-            <a:off x="4480560" y="3337560"/>
-            <a:ext cx="3154680" cy="685800"/>
+          <p:cNvPr id="37" name="Text 35"/>
+          <p:cNvSpPr/>
+          <p:nvPr/>
+        </p:nvSpPr>
+        <p:spPr>
+          <a:xfrm>
+            <a:off x="6629400" y="3456432"/>
+            <a:ext cx="2103120" cy="685800"/>
           </a:xfrm>
           <a:prstGeom prst="rect">
             <a:avLst/>
@@ -18830,7 +19643,7 @@
                 <a:ea typeface="Poppins" pitchFamily="34" charset="-122"/>
                 <a:cs typeface="Poppins" pitchFamily="34" charset="-120"/>
               </a:rPr>
-              <a:t>100 %</a:t>
+              <a:t>57.2 %</a:t>
             </a:r>
             <a:endParaRPr lang="en-US" sz="3400" dirty="0"/>
           </a:p>
@@ -18838,14 +19651,14 @@
       </p:sp>
       <p:sp>
         <p:nvSpPr>
-          <p:cNvPr id="15" name="Text 13"/>
-          <p:cNvSpPr/>
-          <p:nvPr/>
-        </p:nvSpPr>
-        <p:spPr>
-          <a:xfrm>
-            <a:off x="4480560" y="4023360"/>
-            <a:ext cx="3154680" cy="548640"/>
+          <p:cNvPr id="38" name="Text 36"/>
+          <p:cNvSpPr/>
+          <p:nvPr/>
+        </p:nvSpPr>
+        <p:spPr>
+          <a:xfrm>
+            <a:off x="6629400" y="4142232"/>
+            <a:ext cx="2103120" cy="548640"/>
           </a:xfrm>
           <a:prstGeom prst="rect">
             <a:avLst/>
@@ -18869,7 +19682,7 @@
                 <a:ea typeface="Calibri" pitchFamily="34" charset="-122"/>
                 <a:cs typeface="Calibri" pitchFamily="34" charset="-120"/>
               </a:rPr>
-              <a:t>nunca usó una app para esto</a:t>
+              <a:t>no está tranquilo al dejar entrar a un desconocido</a:t>
             </a:r>
             <a:endParaRPr lang="en-US" sz="1300" dirty="0"/>
           </a:p>
@@ -18877,14 +19690,14 @@
       </p:sp>
       <p:sp>
         <p:nvSpPr>
-          <p:cNvPr id="16" name="Shape 14"/>
-          <p:cNvSpPr/>
-          <p:nvPr/>
-        </p:nvSpPr>
-        <p:spPr>
-          <a:xfrm>
-            <a:off x="8046720" y="3200400"/>
-            <a:ext cx="3520440" cy="1463040"/>
+          <p:cNvPr id="39" name="Shape 37"/>
+          <p:cNvSpPr/>
+          <p:nvPr/>
+        </p:nvSpPr>
+        <p:spPr>
+          <a:xfrm>
+            <a:off x="9052560" y="3319272"/>
+            <a:ext cx="2468880" cy="1463040"/>
           </a:xfrm>
           <a:prstGeom prst="roundRect">
             <a:avLst>
@@ -18904,14 +19717,14 @@
       </p:sp>
       <p:sp>
         <p:nvSpPr>
-          <p:cNvPr id="17" name="Text 15"/>
-          <p:cNvSpPr/>
-          <p:nvPr/>
-        </p:nvSpPr>
-        <p:spPr>
-          <a:xfrm>
-            <a:off x="8229600" y="3337560"/>
-            <a:ext cx="3154680" cy="685800"/>
+          <p:cNvPr id="40" name="Text 38"/>
+          <p:cNvSpPr/>
+          <p:nvPr/>
+        </p:nvSpPr>
+        <p:spPr>
+          <a:xfrm>
+            <a:off x="9235440" y="3456432"/>
+            <a:ext cx="2103120" cy="685800"/>
           </a:xfrm>
           <a:prstGeom prst="rect">
             <a:avLst/>
@@ -18929,13 +19742,13 @@
             <a:r>
               <a:rPr lang="en-US" sz="3400" b="1" dirty="0">
                 <a:solidFill>
-                  <a:srgbClr val="E0A100"/>
+                  <a:srgbClr val="B3261E"/>
                 </a:solidFill>
                 <a:latin typeface="Poppins" pitchFamily="34" charset="0"/>
                 <a:ea typeface="Poppins" pitchFamily="34" charset="-122"/>
                 <a:cs typeface="Poppins" pitchFamily="34" charset="-120"/>
               </a:rPr>
-              <a:t>57.2 %</a:t>
+              <a:t>71.4 %</a:t>
             </a:r>
             <a:endParaRPr lang="en-US" sz="3400" dirty="0"/>
           </a:p>
@@ -18943,14 +19756,14 @@
       </p:sp>
       <p:sp>
         <p:nvSpPr>
-          <p:cNvPr id="18" name="Text 16"/>
-          <p:cNvSpPr/>
-          <p:nvPr/>
-        </p:nvSpPr>
-        <p:spPr>
-          <a:xfrm>
-            <a:off x="8229600" y="4023360"/>
-            <a:ext cx="3154680" cy="548640"/>
+          <p:cNvPr id="41" name="Text 39"/>
+          <p:cNvSpPr/>
+          <p:nvPr/>
+        </p:nvSpPr>
+        <p:spPr>
+          <a:xfrm>
+            <a:off x="9235440" y="4142232"/>
+            <a:ext cx="2103120" cy="548640"/>
           </a:xfrm>
           <a:prstGeom prst="rect">
             <a:avLst/>
@@ -18974,7 +19787,7 @@
                 <a:ea typeface="Calibri" pitchFamily="34" charset="-122"/>
                 <a:cs typeface="Calibri" pitchFamily="34" charset="-120"/>
               </a:rPr>
-              <a:t>no está tranquilo al dejar entrar a un desconocido</a:t>
+              <a:t>teme que el trabajo quede mal hecho</a:t>
             </a:r>
             <a:endParaRPr lang="en-US" sz="1300" dirty="0"/>
           </a:p>
@@ -18982,14 +19795,14 @@
       </p:sp>
       <p:sp>
         <p:nvSpPr>
-          <p:cNvPr id="19" name="Shape 17"/>
-          <p:cNvSpPr/>
-          <p:nvPr/>
-        </p:nvSpPr>
-        <p:spPr>
-          <a:xfrm>
-            <a:off x="548640" y="4800600"/>
-            <a:ext cx="3520440" cy="1463040"/>
+          <p:cNvPr id="42" name="Shape 40"/>
+          <p:cNvSpPr/>
+          <p:nvPr/>
+        </p:nvSpPr>
+        <p:spPr>
+          <a:xfrm>
+            <a:off x="6446520" y="4855464"/>
+            <a:ext cx="2468880" cy="1463040"/>
           </a:xfrm>
           <a:prstGeom prst="roundRect">
             <a:avLst>
@@ -19009,14 +19822,14 @@
       </p:sp>
       <p:sp>
         <p:nvSpPr>
-          <p:cNvPr id="20" name="Text 18"/>
-          <p:cNvSpPr/>
-          <p:nvPr/>
-        </p:nvSpPr>
-        <p:spPr>
-          <a:xfrm>
-            <a:off x="731520" y="4937760"/>
-            <a:ext cx="3154680" cy="685800"/>
+          <p:cNvPr id="43" name="Text 41"/>
+          <p:cNvSpPr/>
+          <p:nvPr/>
+        </p:nvSpPr>
+        <p:spPr>
+          <a:xfrm>
+            <a:off x="6629400" y="4992624"/>
+            <a:ext cx="2103120" cy="685800"/>
           </a:xfrm>
           <a:prstGeom prst="rect">
             <a:avLst/>
@@ -19040,7 +19853,7 @@
                 <a:ea typeface="Poppins" pitchFamily="34" charset="-122"/>
                 <a:cs typeface="Poppins" pitchFamily="34" charset="-120"/>
               </a:rPr>
-              <a:t>71.4 %</a:t>
+              <a:t>52.4 %</a:t>
             </a:r>
             <a:endParaRPr lang="en-US" sz="3400" dirty="0"/>
           </a:p>
@@ -19048,14 +19861,14 @@
       </p:sp>
       <p:sp>
         <p:nvSpPr>
-          <p:cNvPr id="21" name="Text 19"/>
-          <p:cNvSpPr/>
-          <p:nvPr/>
-        </p:nvSpPr>
-        <p:spPr>
-          <a:xfrm>
-            <a:off x="731520" y="5623560"/>
-            <a:ext cx="3154680" cy="548640"/>
+          <p:cNvPr id="44" name="Text 42"/>
+          <p:cNvSpPr/>
+          <p:nvPr/>
+        </p:nvSpPr>
+        <p:spPr>
+          <a:xfrm>
+            <a:off x="6629400" y="5678424"/>
+            <a:ext cx="2103120" cy="548640"/>
           </a:xfrm>
           <a:prstGeom prst="rect">
             <a:avLst/>
@@ -19079,7 +19892,7 @@
                 <a:ea typeface="Calibri" pitchFamily="34" charset="-122"/>
                 <a:cs typeface="Calibri" pitchFamily="34" charset="-120"/>
               </a:rPr>
-              <a:t>teme que el trabajo quede mal hecho</a:t>
+              <a:t>ya vivió un trabajo mal hecho</a:t>
             </a:r>
             <a:endParaRPr lang="en-US" sz="1300" dirty="0"/>
           </a:p>
@@ -19087,14 +19900,14 @@
       </p:sp>
       <p:sp>
         <p:nvSpPr>
-          <p:cNvPr id="22" name="Shape 20"/>
-          <p:cNvSpPr/>
-          <p:nvPr/>
-        </p:nvSpPr>
-        <p:spPr>
-          <a:xfrm>
-            <a:off x="4297680" y="4800600"/>
-            <a:ext cx="3520440" cy="1463040"/>
+          <p:cNvPr id="45" name="Shape 43"/>
+          <p:cNvSpPr/>
+          <p:nvPr/>
+        </p:nvSpPr>
+        <p:spPr>
+          <a:xfrm>
+            <a:off x="9052560" y="4855464"/>
+            <a:ext cx="2468880" cy="1463040"/>
           </a:xfrm>
           <a:prstGeom prst="roundRect">
             <a:avLst>
@@ -19114,14 +19927,14 @@
       </p:sp>
       <p:sp>
         <p:nvSpPr>
-          <p:cNvPr id="23" name="Text 21"/>
-          <p:cNvSpPr/>
-          <p:nvPr/>
-        </p:nvSpPr>
-        <p:spPr>
-          <a:xfrm>
-            <a:off x="4480560" y="4937760"/>
-            <a:ext cx="3154680" cy="685800"/>
+          <p:cNvPr id="46" name="Text 44"/>
+          <p:cNvSpPr/>
+          <p:nvPr/>
+        </p:nvSpPr>
+        <p:spPr>
+          <a:xfrm>
+            <a:off x="9235440" y="4992624"/>
+            <a:ext cx="2103120" cy="685800"/>
           </a:xfrm>
           <a:prstGeom prst="rect">
             <a:avLst/>
@@ -19139,13 +19952,13 @@
             <a:r>
               <a:rPr lang="en-US" sz="3400" b="1" dirty="0">
                 <a:solidFill>
-                  <a:srgbClr val="B3261E"/>
+                  <a:srgbClr val="12733F"/>
                 </a:solidFill>
                 <a:latin typeface="Poppins" pitchFamily="34" charset="0"/>
                 <a:ea typeface="Poppins" pitchFamily="34" charset="-122"/>
                 <a:cs typeface="Poppins" pitchFamily="34" charset="-120"/>
               </a:rPr>
-              <a:t>52.4 %</a:t>
+              <a:t>80.9 %</a:t>
             </a:r>
             <a:endParaRPr lang="en-US" sz="3400" dirty="0"/>
           </a:p>
@@ -19153,119 +19966,14 @@
       </p:sp>
       <p:sp>
         <p:nvSpPr>
-          <p:cNvPr id="24" name="Text 22"/>
-          <p:cNvSpPr/>
-          <p:nvPr/>
-        </p:nvSpPr>
-        <p:spPr>
-          <a:xfrm>
-            <a:off x="4480560" y="5623560"/>
-            <a:ext cx="3154680" cy="548640"/>
-          </a:xfrm>
-          <a:prstGeom prst="rect">
-            <a:avLst/>
-          </a:prstGeom>
-          <a:noFill/>
-          <a:ln/>
-        </p:spPr>
-        <p:txBody>
-          <a:bodyPr wrap="square" lIns="0" tIns="0" rIns="0" bIns="0" rtlCol="0" anchor="t"/>
-          <a:lstStyle/>
-          <a:p>
-            <a:pPr indent="0" marL="0">
-              <a:buNone/>
-            </a:pPr>
-            <a:r>
-              <a:rPr lang="en-US" sz="1300" dirty="0">
-                <a:solidFill>
-                  <a:srgbClr val="434C63"/>
-                </a:solidFill>
-                <a:latin typeface="Calibri" pitchFamily="34" charset="0"/>
-                <a:ea typeface="Calibri" pitchFamily="34" charset="-122"/>
-                <a:cs typeface="Calibri" pitchFamily="34" charset="-120"/>
-              </a:rPr>
-              <a:t>ya vivió un trabajo mal hecho</a:t>
-            </a:r>
-            <a:endParaRPr lang="en-US" sz="1300" dirty="0"/>
-          </a:p>
-        </p:txBody>
-      </p:sp>
-      <p:sp>
-        <p:nvSpPr>
-          <p:cNvPr id="25" name="Shape 23"/>
-          <p:cNvSpPr/>
-          <p:nvPr/>
-        </p:nvSpPr>
-        <p:spPr>
-          <a:xfrm>
-            <a:off x="8046720" y="4800600"/>
-            <a:ext cx="3520440" cy="1463040"/>
-          </a:xfrm>
-          <a:prstGeom prst="roundRect">
-            <a:avLst>
-              <a:gd name="adj" fmla="val 7500"/>
-            </a:avLst>
-          </a:prstGeom>
-          <a:solidFill>
-            <a:srgbClr val="F5F6FA"/>
-          </a:solidFill>
-          <a:ln w="12700">
-            <a:solidFill>
-              <a:srgbClr val="F5F6FA"/>
-            </a:solidFill>
-            <a:prstDash val="solid"/>
-          </a:ln>
-        </p:spPr>
-      </p:sp>
-      <p:sp>
-        <p:nvSpPr>
-          <p:cNvPr id="26" name="Text 24"/>
-          <p:cNvSpPr/>
-          <p:nvPr/>
-        </p:nvSpPr>
-        <p:spPr>
-          <a:xfrm>
-            <a:off x="8229600" y="4937760"/>
-            <a:ext cx="3154680" cy="685800"/>
-          </a:xfrm>
-          <a:prstGeom prst="rect">
-            <a:avLst/>
-          </a:prstGeom>
-          <a:noFill/>
-          <a:ln/>
-        </p:spPr>
-        <p:txBody>
-          <a:bodyPr wrap="square" lIns="0" tIns="0" rIns="0" bIns="0" rtlCol="0" anchor="t"/>
-          <a:lstStyle/>
-          <a:p>
-            <a:pPr indent="0" marL="0">
-              <a:buNone/>
-            </a:pPr>
-            <a:r>
-              <a:rPr lang="en-US" sz="3400" b="1" dirty="0">
-                <a:solidFill>
-                  <a:srgbClr val="12733F"/>
-                </a:solidFill>
-                <a:latin typeface="Poppins" pitchFamily="34" charset="0"/>
-                <a:ea typeface="Poppins" pitchFamily="34" charset="-122"/>
-                <a:cs typeface="Poppins" pitchFamily="34" charset="-120"/>
-              </a:rPr>
-              <a:t>80.9 %</a:t>
-            </a:r>
-            <a:endParaRPr lang="en-US" sz="3400" dirty="0"/>
-          </a:p>
-        </p:txBody>
-      </p:sp>
-      <p:sp>
-        <p:nvSpPr>
-          <p:cNvPr id="27" name="Text 25"/>
-          <p:cNvSpPr/>
-          <p:nvPr/>
-        </p:nvSpPr>
-        <p:spPr>
-          <a:xfrm>
-            <a:off x="8229600" y="5623560"/>
-            <a:ext cx="3154680" cy="548640"/>
+          <p:cNvPr id="47" name="Text 45"/>
+          <p:cNvSpPr/>
+          <p:nvPr/>
+        </p:nvSpPr>
+        <p:spPr>
+          <a:xfrm>
+            <a:off x="9235440" y="5678424"/>
+            <a:ext cx="2103120" cy="548640"/>
           </a:xfrm>
           <a:prstGeom prst="rect">
             <a:avLst/>
@@ -22136,7 +22844,7 @@
                 <a:ea typeface="Poppins" pitchFamily="34" charset="-122"/>
                 <a:cs typeface="Poppins" pitchFamily="34" charset="-120"/>
               </a:rPr>
-              <a:t>¿Cómo podríamos garantizar que un trabajo del hogar quede bien hecho desde la primera vez, para que las familias de la Ciudad de Guatemala dejen de depender de la suerte y de la recomendación de un conocido?</a:t>
+              <a:t>¿Cómo podríamos comprobar la identidad y la capacidad técnica de un contratista antes de que entre a nuestra casa, para que las personas dejen de arriesgar su seguridad y su dinero?</a:t>
             </a:r>
             <a:endParaRPr lang="en-US" sz="1550" dirty="0"/>
           </a:p>

</xml_diff>